<commit_message>
Fix table overflow and explain HLE public and held-out sets
</commit_message>
<xml_diff>
--- a/slides/datasets-in-10-minutes-terminal-bench.pptx
+++ b/slides/datasets-in-10-minutes-terminal-bench.pptx
@@ -18387,7 +18387,7 @@
                           <a:ea typeface="Noto Sans CJK JP"/>
                           <a:cs typeface="Noto Sans"/>
                         </a:rPr>
-                        <a:t>参照解法は合格し、何もしないエージェントは失敗</a:t>
+                        <a:t>参照解法は合格し、何もしない場合は失敗</a:t>
                       </a:r>
                     </a:p>
                   </a:txBody>
@@ -21605,7 +21605,7 @@
                           <a:ea typeface="Noto Sans CJK JP"/>
                           <a:cs typeface="Noto Sans"/>
                         </a:rPr>
-                        <a:t>Merrillら（2026）の分類</a:t>
+                        <a:t>分類</a:t>
                       </a:r>
                     </a:p>
                   </a:txBody>
@@ -22805,7 +22805,7 @@
                           <a:ea typeface="Noto Sans CJK JP"/>
                           <a:cs typeface="Noto Sans"/>
                         </a:rPr>
-                        <a:t>HarborがOpus 5.5を使う2.0の実行例を掲載</a:t>
+                        <a:t>HarborにOpus 5.5＋2.0の実行例</a:t>
                       </a:r>
                     </a:p>
                   </a:txBody>
@@ -22910,7 +22910,7 @@
                           <a:ea typeface="Noto Sans CJK JP"/>
                           <a:cs typeface="Noto Sans"/>
                         </a:rPr>
-                        <a:t>GPT-6 Astra・Opus 5.5が4.0の結果を掲載</a:t>
+                        <a:t>GPT-6 Astra・Opus 5.5の4.0評価</a:t>
                       </a:r>
                     </a:p>
                   </a:txBody>
@@ -36038,7 +36038,7 @@
                           <a:ea typeface="Noto Sans CJK JP"/>
                           <a:cs typeface="Noto Sans"/>
                         </a:rPr>
-                        <a:t>課題のDockerfileまたは指定イメージから準備</a:t>
+                        <a:t>Dockerfileまたは指定イメージを使用</a:t>
                       </a:r>
                     </a:p>
                   </a:txBody>
@@ -36442,7 +36442,7 @@
         </p:nvGraphicFramePr>
         <p:xfrm>
           <a:off x="548640" y="1508760"/>
-          <a:ext cx="8046720" cy="2414016"/>
+          <a:ext cx="8046720" cy="2633472"/>
         </p:xfrm>
         <a:graphic>
           <a:graphicData uri="http://schemas.openxmlformats.org/drawingml/2006/table">
@@ -36674,7 +36674,7 @@
                   </a:tcPr>
                 </a:tc>
               </a:tr>
-              <a:tr h="621792">
+              <a:tr h="731520">
                 <a:tc>
                   <a:txBody>
                     <a:bodyPr wrap="square">
@@ -36753,7 +36753,7 @@
                           <a:ea typeface="Noto Sans CJK JP"/>
                           <a:cs typeface="Noto Sans"/>
                         </a:rPr>
-                        <a:t>公式READMEとHarbor README</a:t>
+                        <a:t>公式README／Harbor</a:t>
                       </a:r>
                     </a:p>
                   </a:txBody>
@@ -36776,7 +36776,7 @@
                   </a:tcPr>
                 </a:tc>
               </a:tr>
-              <a:tr h="621792">
+              <a:tr h="731520">
                 <a:tc>
                   <a:txBody>
                     <a:bodyPr wrap="square">
@@ -41096,7 +41096,7 @@
                           <a:ea typeface="Noto Sans CJK JP"/>
                           <a:cs typeface="Noto Sans"/>
                         </a:rPr>
-                        <a:t>中断信号SIGINTを送り、開始したジョブの後始末を確認</a:t>
+                        <a:t>SIGINTで中断し、各ジョブの後始末を確認</a:t>
                       </a:r>
                     </a:p>
                   </a:txBody>

</xml_diff>

<commit_message>
Proofread terminal-bench with Japanese proofreading skill
</commit_message>
<xml_diff>
--- a/slides/datasets-in-10-minutes-terminal-bench.pptx
+++ b/slides/datasets-in-10-minutes-terminal-bench.pptx
@@ -10201,7 +10201,7 @@
                 <a:ea typeface="Noto Sans CJK JP"/>
                 <a:cs typeface="Noto Sans"/>
               </a:rPr>
-              <a:t>全テストに合格すれば成功の1、条件を満たさなければ0を与える。課題には作業時間の上限も設定されている。</a:t>
+              <a:t>全テストに合格すれば成功として1、条件を満たさなければ0を与える。課題には作業時間の上限も設定されている。</a:t>
             </a:r>
           </a:p>
           <a:p>
@@ -12385,7 +12385,7 @@
                           <a:ea typeface="Noto Sans CJK JP"/>
                           <a:cs typeface="Noto Sans"/>
                         </a:rPr>
-                        <a:t>モデル（Google公表表）</a:t>
+                        <a:t>モデル（Google公表値）</a:t>
                       </a:r>
                     </a:p>
                   </a:txBody>
@@ -14521,7 +14521,7 @@
                 <a:ea typeface="Noto Sans CJK JP"/>
                 <a:cs typeface="Noto Sans"/>
               </a:rPr>
-              <a:t>Anthropicは、コマンドライン上で複数の手順を実行する、複雑な実務課題の評価と説明している。</a:t>
+              <a:t>Anthropicは、コマンドライン上で複数の手順を実行する、複雑な実務課題の評価であると説明している。</a:t>
             </a:r>
           </a:p>
           <a:p>
@@ -14841,7 +14841,7 @@
                 <a:ea typeface="Noto Sans CJK JP"/>
                 <a:cs typeface="Noto Sans"/>
               </a:rPr>
-              <a:t>最新モデルの公表表には4.0も採用される</a:t>
+              <a:t>最新モデルの公表評価には4.0も採用される</a:t>
             </a:r>
           </a:p>
         </p:txBody>
@@ -16065,7 +16065,7 @@
                 <a:ea typeface="Noto Sans CJK JP"/>
                 <a:cs typeface="Noto Sans"/>
               </a:rPr>
-              <a:t>各課題には必要なファイルとソフトウェアを用意し、作業結果を自動テストで判定できるようにする。</a:t>
+              <a:t>各課題には必要なファイルとソフトウェアを用意し、作業結果を自動テストで判定できるようにした。</a:t>
             </a:r>
           </a:p>
           <a:p>
@@ -18276,7 +18276,7 @@
                           <a:ea typeface="Noto Sans CJK JP"/>
                           <a:cs typeface="Noto Sans"/>
                         </a:rPr>
-                        <a:t>行う確認</a:t>
+                        <a:t>確認内容</a:t>
                       </a:r>
                     </a:p>
                   </a:txBody>
@@ -18387,7 +18387,7 @@
                           <a:ea typeface="Noto Sans CJK JP"/>
                           <a:cs typeface="Noto Sans"/>
                         </a:rPr>
-                        <a:t>参照解法は合格し、何もしない場合は失敗</a:t>
+                        <a:t>参照解法が合格し、何もしない場合は失敗すること</a:t>
                       </a:r>
                     </a:p>
                   </a:txBody>
@@ -22857,7 +22857,7 @@
                           <a:ea typeface="Noto Sans CJK JP"/>
                           <a:cs typeface="Noto Sans"/>
                         </a:rPr>
-                        <a:t>2026年のモデル公表表</a:t>
+                        <a:t>2026年のモデル公表資料</a:t>
                       </a:r>
                     </a:p>
                   </a:txBody>
@@ -25369,7 +25369,7 @@
                 <a:ea typeface="Noto Sans CJK JP"/>
                 <a:cs typeface="Noto Sans"/>
               </a:rPr>
-              <a:t>Merrillら（2026）による複数エージェントの比較から、現在のモデル評価とHarborによる実行へ利用が続いている。</a:t>
+              <a:t>Merrillら（2026）による複数エージェントの比較から、現在のモデル評価とHarborによる実行への利用が続いている。</a:t>
             </a:r>
           </a:p>
         </p:txBody>
@@ -26643,7 +26643,7 @@
                 <a:ea typeface="Noto Sans CJK JP"/>
                 <a:cs typeface="Noto Sans"/>
               </a:rPr>
-              <a:t>要旨：結び目の計算用ライブラリpyknotidを修正・ビルドする。テストはNumPy 2.3.0の保持、3拡張の読み込み、結び目の計算結果を確認する。</a:t>
+              <a:t>要旨：結び目の計算用ライブラリpyknotidを修正・ビルドする。テストではNumPy 2.3.0の保持、3つの拡張モジュールの読み込み、結び目の計算結果を確認する。</a:t>
             </a:r>
           </a:p>
         </p:txBody>
@@ -28955,7 +28955,7 @@
                 <a:ea typeface="Noto Sans CJK JP"/>
                 <a:cs typeface="Noto Sans"/>
               </a:rPr>
-              <a:t>要旨：グラフェン試料のスペクトルにG・2Dのピークを当てはめ、中心位置・幅・振幅・オフセットをJSONへ保存する。採点はパラメータごとの許容範囲を確認する。</a:t>
+              <a:t>要旨：グラフェン試料のスペクトルにG・2Dのピークを当てはめ、中心位置・幅・振幅・オフセットをJSONへ保存する。採点ではパラメータごとの許容範囲を確認する。</a:t>
             </a:r>
           </a:p>
         </p:txBody>
@@ -29791,7 +29791,7 @@
                 <a:ea typeface="Noto Sans CJK JP"/>
                 <a:cs typeface="Noto Sans"/>
               </a:rPr>
-              <a:t>要旨：証明支援系Coqで、不完全な帰納法の証明を完成させる。採点は証明の完了と、coqcによるコンパイルを確認する。</a:t>
+              <a:t>要旨：証明支援系Coqで、不完全な帰納法の証明を完成させる。採点では証明の完了と、coqcによるコンパイルを確認する。</a:t>
             </a:r>
           </a:p>
         </p:txBody>

</xml_diff>